<commit_message>
feat: add production deployment scripts, update docs, regenerate PPT
- Add comprehensive deployment scripts (deploy.sh, rollback.sh, health-check.sh, backup-db.sh)
- Add Docker Compose configuration with PostgreSQL, Nginx, and optional Redis
- Add Dockerfile with multi-stage build for production
- Add Nginx configuration with SSL, rate limiting, and gzip compression
- Update USER_GUIDE.md with new settings pages documentation
- Update README.md with new features (25+ templates, admin features)
- Update DEPLOYMENT.md with production deployment scripts documentation
- Add 4 new detailed CR templates (API Deprecation, DC Migration, Third-Party Integration, Compliance Remediation)
- Fix riskLevel type (remove very_high)
- Regenerate PPT slides with updated content for v1.4.0
</commit_message>
<xml_diff>
--- a/docs/GCS_Change_Release_Dashboard.pptx
+++ b/docs/GCS_Change_Release_Dashboard.pptx
@@ -2740,7 +2740,7 @@
                 <a:ea typeface="Arial" pitchFamily="34" charset="-122"/>
                 <a:cs typeface="Arial" pitchFamily="34" charset="-120"/>
               </a:rPr>
-              <a:t>April 2026  |  GCS Engineering  |  v1.3.0</a:t>
+              <a:t>May 2026  |  GCS Engineering  |  v1.4.0</a:t>
             </a:r>
             <a:endParaRPr lang="en-US" sz="1400" dirty="0"/>
           </a:p>
@@ -16586,7 +16586,7 @@
                 <a:ea typeface="Arial" pitchFamily="34" charset="-122"/>
                 <a:cs typeface="Arial" pitchFamily="34" charset="-120"/>
               </a:rPr>
-              <a:t>✅ Code change analysis + feature impact</a:t>
+              <a:t>✅ 25+ detailed CR templates</a:t>
             </a:r>
             <a:endParaRPr lang="en-US" sz="1000" dirty="0"/>
           </a:p>
@@ -16625,7 +16625,7 @@
                 <a:ea typeface="Arial" pitchFamily="34" charset="-122"/>
                 <a:cs typeface="Arial" pitchFamily="34" charset="-120"/>
               </a:rPr>
-              <a:t>✅ Per-user data isolation &amp; credentials</a:t>
+              <a:t>✅ Multi-tenancy &amp; org management</a:t>
             </a:r>
             <a:endParaRPr lang="en-US" sz="1000" dirty="0"/>
           </a:p>
@@ -16664,7 +16664,7 @@
                 <a:ea typeface="Arial" pitchFamily="34" charset="-122"/>
                 <a:cs typeface="Arial" pitchFamily="34" charset="-120"/>
               </a:rPr>
-              <a:t>✅ Analytics suite (4 tabs)</a:t>
+              <a:t>✅ Docker deployment scripts</a:t>
             </a:r>
             <a:endParaRPr lang="en-US" sz="1000" dirty="0"/>
           </a:p>
@@ -16703,7 +16703,7 @@
                 <a:ea typeface="Arial" pitchFamily="34" charset="-122"/>
                 <a:cs typeface="Arial" pitchFamily="34" charset="-120"/>
               </a:rPr>
-              <a:t>✅ 113 unit tests + architecture docs</a:t>
+              <a:t>✅ 450+ unit tests + architecture docs</a:t>
             </a:r>
             <a:endParaRPr lang="en-US" sz="1000" dirty="0"/>
           </a:p>
@@ -16852,7 +16852,7 @@
                 <a:ea typeface="Arial" pitchFamily="34" charset="-122"/>
                 <a:cs typeface="Arial" pitchFamily="34" charset="-120"/>
               </a:rPr>
-              <a:t>🔲 PostgreSQL production database</a:t>
+              <a:t>🔲 Automated SN sync (webhook/cron)</a:t>
             </a:r>
             <a:endParaRPr lang="en-US" sz="1000" dirty="0"/>
           </a:p>
@@ -16891,7 +16891,7 @@
                 <a:ea typeface="Arial" pitchFamily="34" charset="-122"/>
                 <a:cs typeface="Arial" pitchFamily="34" charset="-120"/>
               </a:rPr>
-              <a:t>🔲 Automated SN sync (webhook/cron)</a:t>
+              <a:t>🔲 Email notifications for high-risk CRs</a:t>
             </a:r>
             <a:endParaRPr lang="en-US" sz="1000" dirty="0"/>
           </a:p>
@@ -16930,7 +16930,7 @@
                 <a:ea typeface="Arial" pitchFamily="34" charset="-122"/>
                 <a:cs typeface="Arial" pitchFamily="34" charset="-120"/>
               </a:rPr>
-              <a:t>🔲 Email notifications for high-risk CRs</a:t>
+              <a:t>🔲 Custom scoring weight presets</a:t>
             </a:r>
             <a:endParaRPr lang="en-US" sz="1000" dirty="0"/>
           </a:p>
@@ -16969,7 +16969,7 @@
                 <a:ea typeface="Arial" pitchFamily="34" charset="-122"/>
                 <a:cs typeface="Arial" pitchFamily="34" charset="-120"/>
               </a:rPr>
-              <a:t>🔲 Custom scoring weight presets</a:t>
+              <a:t>🔲 Exportable reports (PDF/Excel)</a:t>
             </a:r>
             <a:endParaRPr lang="en-US" sz="1000" dirty="0"/>
           </a:p>
@@ -17008,7 +17008,7 @@
                 <a:ea typeface="Arial" pitchFamily="34" charset="-122"/>
                 <a:cs typeface="Arial" pitchFamily="34" charset="-120"/>
               </a:rPr>
-              <a:t>🔲 Exportable reports (PDF/Excel)</a:t>
+              <a:t>🔲 E2E tests with Playwright</a:t>
             </a:r>
             <a:endParaRPr lang="en-US" sz="1000" dirty="0"/>
           </a:p>
@@ -17047,7 +17047,7 @@
                 <a:ea typeface="Arial" pitchFamily="34" charset="-122"/>
                 <a:cs typeface="Arial" pitchFamily="34" charset="-120"/>
               </a:rPr>
-              <a:t>🔲 E2E tests with Playwright</a:t>
+              <a:t>🔲 Kubernetes Helm charts</a:t>
             </a:r>
             <a:endParaRPr lang="en-US" sz="1000" dirty="0"/>
           </a:p>
@@ -18298,7 +18298,7 @@
                 <a:ea typeface="Arial" pitchFamily="34" charset="-122"/>
                 <a:cs typeface="Arial" pitchFamily="34" charset="-120"/>
               </a:rPr>
-              <a:t>Production Outage &amp; Performance Detection</a:t>
+              <a:t>CR Templates &amp; Workflow Engine</a:t>
             </a:r>
             <a:endParaRPr lang="en-US" sz="1400" dirty="0"/>
           </a:p>
@@ -18380,7 +18380,7 @@
                 <a:ea typeface="Arial" pitchFamily="34" charset="-122"/>
                 <a:cs typeface="Arial" pitchFamily="34" charset="-120"/>
               </a:rPr>
-              <a:t>Analytics &amp; Advanced Pages</a:t>
+              <a:t>Multi-Tenancy &amp; Admin Features</a:t>
             </a:r>
             <a:endParaRPr lang="en-US" sz="1400" dirty="0"/>
           </a:p>
@@ -18462,7 +18462,7 @@
                 <a:ea typeface="Arial" pitchFamily="34" charset="-122"/>
                 <a:cs typeface="Arial" pitchFamily="34" charset="-120"/>
               </a:rPr>
-              <a:t>Authentication &amp; Role-Based Access</a:t>
+              <a:t>Production Deployment</a:t>
             </a:r>
             <a:endParaRPr lang="en-US" sz="1400" dirty="0"/>
           </a:p>

</xml_diff>